<commit_message>
Add cylinder EGT bank asymmetry slides to DML log analysis presentation
Appended 10 new slides (section divider + 9 unit slides) to
DML_Анализ_LogFiles_NTE200.pptx. Each slide shows А-bank (odd
cylinders ECM144, warm YlOrRd palette) and В-bank (even cylinders
ECM1, cool palette) EGT time series side by side with 500°C/550°C
reference lines, per-bank avg/max stats boxes, and a bottom
conclusion bar. Mirrors slide 39 style from main presentation.

https://claude.ai/code/session_01C99rvSEB9BzW7Q9nbisCyZ
</commit_message>
<xml_diff>
--- a/DML_Анализ_LogFiles_NTE200.pptx
+++ b/DML_Анализ_LogFiles_NTE200.pptx
@@ -17,6 +17,16 @@
     <p:sldId id="265" r:id="rId16"/>
     <p:sldId id="266" r:id="rId17"/>
     <p:sldId id="267" r:id="rId18"/>
+    <p:sldId id="268" r:id="rId19"/>
+    <p:sldId id="269" r:id="rId20"/>
+    <p:sldId id="270" r:id="rId21"/>
+    <p:sldId id="271" r:id="rId22"/>
+    <p:sldId id="272" r:id="rId23"/>
+    <p:sldId id="273" r:id="rId24"/>
+    <p:sldId id="274" r:id="rId25"/>
+    <p:sldId id="275" r:id="rId26"/>
+    <p:sldId id="276" r:id="rId27"/>
+    <p:sldId id="277" r:id="rId28"/>
   </p:sldIdLst>
   <p:sldSz cx="12189600" cy="6858000" type="screen4x3"/>
   <p:notesSz cx="6858000" cy="9144000"/>
@@ -7422,6 +7432,1952 @@
 </p:sld>
 </file>
 
+<file path=ppt/slides/slide13.xml><?xml version="1.0" encoding="utf-8"?>
+<p:sld xmlns:a="http://schemas.openxmlformats.org/drawingml/2006/main" xmlns:p="http://schemas.openxmlformats.org/presentationml/2006/main" xmlns:r="http://schemas.openxmlformats.org/officeDocument/2006/relationships">
+  <p:cSld>
+    <p:bg>
+      <p:bgPr>
+        <a:solidFill>
+          <a:srgbClr val="293136"/>
+        </a:solidFill>
+        <a:effectLst/>
+      </p:bgPr>
+    </p:bg>
+    <p:spTree>
+      <p:nvGrpSpPr>
+        <p:cNvPr id="1" name=""/>
+        <p:cNvGrpSpPr/>
+        <p:nvPr/>
+      </p:nvGrpSpPr>
+      <p:grpSpPr/>
+      <p:sp>
+        <p:nvSpPr>
+          <p:cNvPr id="2" name="Rectangle 1"/>
+          <p:cNvSpPr/>
+          <p:nvPr/>
+        </p:nvSpPr>
+        <p:spPr>
+          <a:xfrm>
+            <a:off x="0" y="2340000"/>
+            <a:ext cx="12189600" cy="2160000"/>
+          </a:xfrm>
+          <a:prstGeom prst="rect">
+            <a:avLst/>
+          </a:prstGeom>
+          <a:solidFill>
+            <a:srgbClr val="20272B"/>
+          </a:solidFill>
+          <a:ln>
+            <a:noFill/>
+          </a:ln>
+        </p:spPr>
+        <p:style>
+          <a:lnRef idx="1">
+            <a:schemeClr val="accent1"/>
+          </a:lnRef>
+          <a:fillRef idx="3">
+            <a:schemeClr val="accent1"/>
+          </a:fillRef>
+          <a:effectRef idx="2">
+            <a:schemeClr val="accent1"/>
+          </a:effectRef>
+          <a:fontRef idx="minor">
+            <a:schemeClr val="lt1"/>
+          </a:fontRef>
+        </p:style>
+        <p:txBody>
+          <a:bodyPr rtlCol="0" anchor="ctr"/>
+          <a:lstStyle/>
+          <a:p>
+            <a:pPr algn="ctr"/>
+          </a:p>
+        </p:txBody>
+      </p:sp>
+      <p:sp>
+        <p:nvSpPr>
+          <p:cNvPr id="3" name="Rectangle 2"/>
+          <p:cNvSpPr/>
+          <p:nvPr/>
+        </p:nvSpPr>
+        <p:spPr>
+          <a:xfrm>
+            <a:off x="0" y="2340000"/>
+            <a:ext cx="12189600" cy="108000"/>
+          </a:xfrm>
+          <a:prstGeom prst="rect">
+            <a:avLst/>
+          </a:prstGeom>
+          <a:solidFill>
+            <a:srgbClr val="3EF0AF"/>
+          </a:solidFill>
+          <a:ln>
+            <a:noFill/>
+          </a:ln>
+        </p:spPr>
+        <p:style>
+          <a:lnRef idx="1">
+            <a:schemeClr val="accent1"/>
+          </a:lnRef>
+          <a:fillRef idx="3">
+            <a:schemeClr val="accent1"/>
+          </a:fillRef>
+          <a:effectRef idx="2">
+            <a:schemeClr val="accent1"/>
+          </a:effectRef>
+          <a:fontRef idx="minor">
+            <a:schemeClr val="lt1"/>
+          </a:fontRef>
+        </p:style>
+        <p:txBody>
+          <a:bodyPr rtlCol="0" anchor="ctr"/>
+          <a:lstStyle/>
+          <a:p>
+            <a:pPr algn="ctr"/>
+          </a:p>
+        </p:txBody>
+      </p:sp>
+      <p:sp>
+        <p:nvSpPr>
+          <p:cNvPr id="4" name="TextBox 3"/>
+          <p:cNvSpPr txBox="1"/>
+          <p:nvPr/>
+        </p:nvSpPr>
+        <p:spPr>
+          <a:xfrm>
+            <a:off x="2520000" y="2628000"/>
+            <a:ext cx="9000000" cy="900000"/>
+          </a:xfrm>
+          <a:prstGeom prst="rect">
+            <a:avLst/>
+          </a:prstGeom>
+          <a:noFill/>
+        </p:spPr>
+        <p:txBody>
+          <a:bodyPr wrap="square">
+            <a:spAutoFit/>
+          </a:bodyPr>
+          <a:lstStyle/>
+          <a:p>
+            <a:pPr algn="l"/>
+            <a:r>
+              <a:rPr sz="4400" b="1" i="0">
+                <a:solidFill>
+                  <a:srgbClr val="FFFFFF"/>
+                </a:solidFill>
+              </a:rPr>
+              <a:t>ТЕМПЕРАТУРА</a:t>
+            </a:r>
+          </a:p>
+        </p:txBody>
+      </p:sp>
+      <p:sp>
+        <p:nvSpPr>
+          <p:cNvPr id="5" name="TextBox 4"/>
+          <p:cNvSpPr txBox="1"/>
+          <p:nvPr/>
+        </p:nvSpPr>
+        <p:spPr>
+          <a:xfrm>
+            <a:off x="2520000" y="3456000"/>
+            <a:ext cx="9000000" cy="720000"/>
+          </a:xfrm>
+          <a:prstGeom prst="rect">
+            <a:avLst/>
+          </a:prstGeom>
+          <a:noFill/>
+        </p:spPr>
+        <p:txBody>
+          <a:bodyPr wrap="square">
+            <a:spAutoFit/>
+          </a:bodyPr>
+          <a:lstStyle/>
+          <a:p>
+            <a:pPr algn="l"/>
+            <a:r>
+              <a:rPr sz="4400" b="1" i="0">
+                <a:solidFill>
+                  <a:srgbClr val="3EF0AF"/>
+                </a:solidFill>
+              </a:rPr>
+              <a:t>ПО ЦИЛИНДРАМ</a:t>
+            </a:r>
+          </a:p>
+        </p:txBody>
+      </p:sp>
+      <p:sp>
+        <p:nvSpPr>
+          <p:cNvPr id="6" name="TextBox 5"/>
+          <p:cNvSpPr txBox="1"/>
+          <p:nvPr/>
+        </p:nvSpPr>
+        <p:spPr>
+          <a:xfrm>
+            <a:off x="2520000" y="4320000"/>
+            <a:ext cx="9000000" cy="360000"/>
+          </a:xfrm>
+          <a:prstGeom prst="rect">
+            <a:avLst/>
+          </a:prstGeom>
+          <a:noFill/>
+        </p:spPr>
+        <p:txBody>
+          <a:bodyPr wrap="square">
+            <a:spAutoFit/>
+          </a:bodyPr>
+          <a:lstStyle/>
+          <a:p>
+            <a:pPr algn="l"/>
+            <a:r>
+              <a:rPr sz="1300" b="0" i="0">
+                <a:solidFill>
+                  <a:srgbClr val="667788"/>
+                </a:solidFill>
+              </a:rPr>
+              <a:t>А-банк (ECM144) vs В-банк (ECM1)  |  Все 9 агрегатов  |  16–21 мая 2026</a:t>
+            </a:r>
+          </a:p>
+        </p:txBody>
+      </p:sp>
+      <p:sp>
+        <p:nvSpPr>
+          <p:cNvPr id="7" name="TextBox 6"/>
+          <p:cNvSpPr txBox="1"/>
+          <p:nvPr/>
+        </p:nvSpPr>
+        <p:spPr>
+          <a:xfrm>
+            <a:off x="540000" y="2700000"/>
+            <a:ext cx="1800000" cy="1080000"/>
+          </a:xfrm>
+          <a:prstGeom prst="rect">
+            <a:avLst/>
+          </a:prstGeom>
+          <a:noFill/>
+        </p:spPr>
+        <p:txBody>
+          <a:bodyPr wrap="square">
+            <a:spAutoFit/>
+          </a:bodyPr>
+          <a:lstStyle/>
+          <a:p>
+            <a:pPr algn="l"/>
+            <a:r>
+              <a:rPr sz="7200" b="1" i="0">
+                <a:solidFill>
+                  <a:srgbClr val="3EF0AF"/>
+                </a:solidFill>
+              </a:rPr>
+              <a:t>09</a:t>
+            </a:r>
+          </a:p>
+        </p:txBody>
+      </p:sp>
+    </p:spTree>
+  </p:cSld>
+  <p:clrMapOvr>
+    <a:masterClrMapping/>
+  </p:clrMapOvr>
+</p:sld>
+</file>
+
+<file path=ppt/slides/slide14.xml><?xml version="1.0" encoding="utf-8"?>
+<p:sld xmlns:a="http://schemas.openxmlformats.org/drawingml/2006/main" xmlns:p="http://schemas.openxmlformats.org/presentationml/2006/main" xmlns:r="http://schemas.openxmlformats.org/officeDocument/2006/relationships">
+  <p:cSld>
+    <p:bg>
+      <p:bgPr>
+        <a:solidFill>
+          <a:srgbClr val="293136"/>
+        </a:solidFill>
+        <a:effectLst/>
+      </p:bgPr>
+    </p:bg>
+    <p:spTree>
+      <p:nvGrpSpPr>
+        <p:cNvPr id="1" name=""/>
+        <p:cNvGrpSpPr/>
+        <p:nvPr/>
+      </p:nvGrpSpPr>
+      <p:grpSpPr/>
+      <p:sp>
+        <p:nvSpPr>
+          <p:cNvPr id="2" name="Rectangle 1"/>
+          <p:cNvSpPr/>
+          <p:nvPr/>
+        </p:nvSpPr>
+        <p:spPr>
+          <a:xfrm>
+            <a:off x="0" y="0"/>
+            <a:ext cx="12189600" cy="720000"/>
+          </a:xfrm>
+          <a:prstGeom prst="rect">
+            <a:avLst/>
+          </a:prstGeom>
+          <a:solidFill>
+            <a:srgbClr val="20272B"/>
+          </a:solidFill>
+          <a:ln>
+            <a:noFill/>
+          </a:ln>
+        </p:spPr>
+        <p:style>
+          <a:lnRef idx="1">
+            <a:schemeClr val="accent1"/>
+          </a:lnRef>
+          <a:fillRef idx="3">
+            <a:schemeClr val="accent1"/>
+          </a:fillRef>
+          <a:effectRef idx="2">
+            <a:schemeClr val="accent1"/>
+          </a:effectRef>
+          <a:fontRef idx="minor">
+            <a:schemeClr val="lt1"/>
+          </a:fontRef>
+        </p:style>
+        <p:txBody>
+          <a:bodyPr rtlCol="0" anchor="ctr"/>
+          <a:lstStyle/>
+          <a:p>
+            <a:pPr algn="ctr"/>
+          </a:p>
+        </p:txBody>
+      </p:sp>
+      <p:sp>
+        <p:nvSpPr>
+          <p:cNvPr id="3" name="Rectangle 2"/>
+          <p:cNvSpPr/>
+          <p:nvPr/>
+        </p:nvSpPr>
+        <p:spPr>
+          <a:xfrm>
+            <a:off x="0" y="666000"/>
+            <a:ext cx="12189600" cy="43200"/>
+          </a:xfrm>
+          <a:prstGeom prst="rect">
+            <a:avLst/>
+          </a:prstGeom>
+          <a:solidFill>
+            <a:srgbClr val="3EF0AF"/>
+          </a:solidFill>
+          <a:ln>
+            <a:noFill/>
+          </a:ln>
+        </p:spPr>
+        <p:style>
+          <a:lnRef idx="1">
+            <a:schemeClr val="accent1"/>
+          </a:lnRef>
+          <a:fillRef idx="3">
+            <a:schemeClr val="accent1"/>
+          </a:fillRef>
+          <a:effectRef idx="2">
+            <a:schemeClr val="accent1"/>
+          </a:effectRef>
+          <a:fontRef idx="minor">
+            <a:schemeClr val="lt1"/>
+          </a:fontRef>
+        </p:style>
+        <p:txBody>
+          <a:bodyPr rtlCol="0" anchor="ctr"/>
+          <a:lstStyle/>
+          <a:p>
+            <a:pPr algn="ctr"/>
+          </a:p>
+        </p:txBody>
+      </p:sp>
+      <p:sp>
+        <p:nvSpPr>
+          <p:cNvPr id="4" name="TextBox 3"/>
+          <p:cNvSpPr txBox="1"/>
+          <p:nvPr/>
+        </p:nvSpPr>
+        <p:spPr>
+          <a:xfrm>
+            <a:off x="180000" y="36000"/>
+            <a:ext cx="11520000" cy="396000"/>
+          </a:xfrm>
+          <a:prstGeom prst="rect">
+            <a:avLst/>
+          </a:prstGeom>
+          <a:noFill/>
+        </p:spPr>
+        <p:txBody>
+          <a:bodyPr wrap="square">
+            <a:spAutoFit/>
+          </a:bodyPr>
+          <a:lstStyle/>
+          <a:p>
+            <a:pPr algn="l"/>
+            <a:r>
+              <a:rPr sz="1600" b="1" i="0">
+                <a:solidFill>
+                  <a:srgbClr val="FFFFFF"/>
+                </a:solidFill>
+              </a:rPr>
+              <a:t>ТЕМПЕРАТУРА ЦИЛИНДРОВ — АГРЕГАТ #43 (клапан)  |  16.05.2026</a:t>
+            </a:r>
+          </a:p>
+        </p:txBody>
+      </p:sp>
+      <p:sp>
+        <p:nvSpPr>
+          <p:cNvPr id="5" name="TextBox 4"/>
+          <p:cNvSpPr txBox="1"/>
+          <p:nvPr/>
+        </p:nvSpPr>
+        <p:spPr>
+          <a:xfrm>
+            <a:off x="180000" y="432000"/>
+            <a:ext cx="11520000" cy="234000"/>
+          </a:xfrm>
+          <a:prstGeom prst="rect">
+            <a:avLst/>
+          </a:prstGeom>
+          <a:noFill/>
+        </p:spPr>
+        <p:txBody>
+          <a:bodyPr wrap="square">
+            <a:spAutoFit/>
+          </a:bodyPr>
+          <a:lstStyle/>
+          <a:p>
+            <a:pPr algn="l"/>
+            <a:r>
+              <a:rPr sz="950" b="0" i="0">
+                <a:solidFill>
+                  <a:srgbClr val="667788"/>
+                </a:solidFill>
+              </a:rPr>
+              <a:t>А-банк (нечётные, ECM144) — В-банк (чётные, ECM1)  |  Индивидуальные ЕГТ по цилиндрам</a:t>
+            </a:r>
+          </a:p>
+        </p:txBody>
+      </p:sp>
+      <p:pic>
+        <p:nvPicPr>
+          <p:cNvPr id="6" name="Picture 5" descr="tmp23s4fo2y.png"/>
+          <p:cNvPicPr>
+            <a:picLocks noChangeAspect="1"/>
+          </p:cNvPicPr>
+          <p:nvPr/>
+        </p:nvPicPr>
+        <p:blipFill>
+          <a:blip r:embed="rId2"/>
+          <a:stretch>
+            <a:fillRect/>
+          </a:stretch>
+        </p:blipFill>
+        <p:spPr>
+          <a:xfrm>
+            <a:off x="108000" y="756000"/>
+            <a:ext cx="11952000" cy="5580000"/>
+          </a:xfrm>
+          <a:prstGeom prst="rect">
+            <a:avLst/>
+          </a:prstGeom>
+        </p:spPr>
+      </p:pic>
+      <p:sp>
+        <p:nvSpPr>
+          <p:cNvPr id="7" name="Rectangle 6"/>
+          <p:cNvSpPr/>
+          <p:nvPr/>
+        </p:nvSpPr>
+        <p:spPr>
+          <a:xfrm>
+            <a:off x="0" y="6372000"/>
+            <a:ext cx="12189600" cy="486000"/>
+          </a:xfrm>
+          <a:prstGeom prst="rect">
+            <a:avLst/>
+          </a:prstGeom>
+          <a:solidFill>
+            <a:srgbClr val="20272B"/>
+          </a:solidFill>
+          <a:ln w="15240">
+            <a:solidFill>
+              <a:srgbClr val="FF8C42"/>
+            </a:solidFill>
+          </a:ln>
+        </p:spPr>
+        <p:style>
+          <a:lnRef idx="1">
+            <a:schemeClr val="accent1"/>
+          </a:lnRef>
+          <a:fillRef idx="3">
+            <a:schemeClr val="accent1"/>
+          </a:fillRef>
+          <a:effectRef idx="2">
+            <a:schemeClr val="accent1"/>
+          </a:effectRef>
+          <a:fontRef idx="minor">
+            <a:schemeClr val="lt1"/>
+          </a:fontRef>
+        </p:style>
+        <p:txBody>
+          <a:bodyPr rtlCol="0" anchor="ctr"/>
+          <a:lstStyle/>
+          <a:p>
+            <a:pPr algn="ctr"/>
+          </a:p>
+        </p:txBody>
+      </p:sp>
+      <p:sp>
+        <p:nvSpPr>
+          <p:cNvPr id="8" name="TextBox 7"/>
+          <p:cNvSpPr txBox="1"/>
+          <p:nvPr/>
+        </p:nvSpPr>
+        <p:spPr>
+          <a:xfrm>
+            <a:off x="180000" y="6390000"/>
+            <a:ext cx="11700000" cy="450000"/>
+          </a:xfrm>
+          <a:prstGeom prst="rect">
+            <a:avLst/>
+          </a:prstGeom>
+          <a:noFill/>
+        </p:spPr>
+        <p:txBody>
+          <a:bodyPr wrap="square">
+            <a:spAutoFit/>
+          </a:bodyPr>
+          <a:lstStyle/>
+          <a:p>
+            <a:pPr algn="l"/>
+            <a:r>
+              <a:rPr sz="1000" b="1" i="0">
+                <a:solidFill>
+                  <a:srgbClr val="FF8C42"/>
+                </a:solidFill>
+              </a:rPr>
+              <a:t>ВЫВОД: В-банк горячее А-банка на 19°C в среднем. Цил.6 достигает 594°C — КРИТИЧНО. Агрегат с известным дефектом клапана — сравнение с нормой.</a:t>
+            </a:r>
+          </a:p>
+        </p:txBody>
+      </p:sp>
+    </p:spTree>
+  </p:cSld>
+  <p:clrMapOvr>
+    <a:masterClrMapping/>
+  </p:clrMapOvr>
+</p:sld>
+</file>
+
+<file path=ppt/slides/slide15.xml><?xml version="1.0" encoding="utf-8"?>
+<p:sld xmlns:a="http://schemas.openxmlformats.org/drawingml/2006/main" xmlns:p="http://schemas.openxmlformats.org/presentationml/2006/main" xmlns:r="http://schemas.openxmlformats.org/officeDocument/2006/relationships">
+  <p:cSld>
+    <p:bg>
+      <p:bgPr>
+        <a:solidFill>
+          <a:srgbClr val="293136"/>
+        </a:solidFill>
+        <a:effectLst/>
+      </p:bgPr>
+    </p:bg>
+    <p:spTree>
+      <p:nvGrpSpPr>
+        <p:cNvPr id="1" name=""/>
+        <p:cNvGrpSpPr/>
+        <p:nvPr/>
+      </p:nvGrpSpPr>
+      <p:grpSpPr/>
+      <p:sp>
+        <p:nvSpPr>
+          <p:cNvPr id="2" name="Rectangle 1"/>
+          <p:cNvSpPr/>
+          <p:nvPr/>
+        </p:nvSpPr>
+        <p:spPr>
+          <a:xfrm>
+            <a:off x="0" y="0"/>
+            <a:ext cx="12189600" cy="720000"/>
+          </a:xfrm>
+          <a:prstGeom prst="rect">
+            <a:avLst/>
+          </a:prstGeom>
+          <a:solidFill>
+            <a:srgbClr val="20272B"/>
+          </a:solidFill>
+          <a:ln>
+            <a:noFill/>
+          </a:ln>
+        </p:spPr>
+        <p:style>
+          <a:lnRef idx="1">
+            <a:schemeClr val="accent1"/>
+          </a:lnRef>
+          <a:fillRef idx="3">
+            <a:schemeClr val="accent1"/>
+          </a:fillRef>
+          <a:effectRef idx="2">
+            <a:schemeClr val="accent1"/>
+          </a:effectRef>
+          <a:fontRef idx="minor">
+            <a:schemeClr val="lt1"/>
+          </a:fontRef>
+        </p:style>
+        <p:txBody>
+          <a:bodyPr rtlCol="0" anchor="ctr"/>
+          <a:lstStyle/>
+          <a:p>
+            <a:pPr algn="ctr"/>
+          </a:p>
+        </p:txBody>
+      </p:sp>
+      <p:sp>
+        <p:nvSpPr>
+          <p:cNvPr id="3" name="Rectangle 2"/>
+          <p:cNvSpPr/>
+          <p:nvPr/>
+        </p:nvSpPr>
+        <p:spPr>
+          <a:xfrm>
+            <a:off x="0" y="666000"/>
+            <a:ext cx="12189600" cy="43200"/>
+          </a:xfrm>
+          <a:prstGeom prst="rect">
+            <a:avLst/>
+          </a:prstGeom>
+          <a:solidFill>
+            <a:srgbClr val="3EF0AF"/>
+          </a:solidFill>
+          <a:ln>
+            <a:noFill/>
+          </a:ln>
+        </p:spPr>
+        <p:style>
+          <a:lnRef idx="1">
+            <a:schemeClr val="accent1"/>
+          </a:lnRef>
+          <a:fillRef idx="3">
+            <a:schemeClr val="accent1"/>
+          </a:fillRef>
+          <a:effectRef idx="2">
+            <a:schemeClr val="accent1"/>
+          </a:effectRef>
+          <a:fontRef idx="minor">
+            <a:schemeClr val="lt1"/>
+          </a:fontRef>
+        </p:style>
+        <p:txBody>
+          <a:bodyPr rtlCol="0" anchor="ctr"/>
+          <a:lstStyle/>
+          <a:p>
+            <a:pPr algn="ctr"/>
+          </a:p>
+        </p:txBody>
+      </p:sp>
+      <p:sp>
+        <p:nvSpPr>
+          <p:cNvPr id="4" name="TextBox 3"/>
+          <p:cNvSpPr txBox="1"/>
+          <p:nvPr/>
+        </p:nvSpPr>
+        <p:spPr>
+          <a:xfrm>
+            <a:off x="180000" y="36000"/>
+            <a:ext cx="11520000" cy="396000"/>
+          </a:xfrm>
+          <a:prstGeom prst="rect">
+            <a:avLst/>
+          </a:prstGeom>
+          <a:noFill/>
+        </p:spPr>
+        <p:txBody>
+          <a:bodyPr wrap="square">
+            <a:spAutoFit/>
+          </a:bodyPr>
+          <a:lstStyle/>
+          <a:p>
+            <a:pPr algn="l"/>
+            <a:r>
+              <a:rPr sz="1600" b="1" i="0">
+                <a:solidFill>
+                  <a:srgbClr val="FFFFFF"/>
+                </a:solidFill>
+              </a:rPr>
+              <a:t>ТЕМПЕРАТУРА ЦИЛИНДРОВ — АГРЕГАТ #45  |  18.05.2026</a:t>
+            </a:r>
+          </a:p>
+        </p:txBody>
+      </p:sp>
+      <p:sp>
+        <p:nvSpPr>
+          <p:cNvPr id="5" name="TextBox 4"/>
+          <p:cNvSpPr txBox="1"/>
+          <p:nvPr/>
+        </p:nvSpPr>
+        <p:spPr>
+          <a:xfrm>
+            <a:off x="180000" y="432000"/>
+            <a:ext cx="11520000" cy="234000"/>
+          </a:xfrm>
+          <a:prstGeom prst="rect">
+            <a:avLst/>
+          </a:prstGeom>
+          <a:noFill/>
+        </p:spPr>
+        <p:txBody>
+          <a:bodyPr wrap="square">
+            <a:spAutoFit/>
+          </a:bodyPr>
+          <a:lstStyle/>
+          <a:p>
+            <a:pPr algn="l"/>
+            <a:r>
+              <a:rPr sz="950" b="0" i="0">
+                <a:solidFill>
+                  <a:srgbClr val="667788"/>
+                </a:solidFill>
+              </a:rPr>
+              <a:t>А-банк (нечётные, ECM144) — В-банк (чётные, ECM1)  |  Индивидуальные ЕГТ по цилиндрам</a:t>
+            </a:r>
+          </a:p>
+        </p:txBody>
+      </p:sp>
+      <p:pic>
+        <p:nvPicPr>
+          <p:cNvPr id="6" name="Picture 5" descr="tmp2ka67x5s.png"/>
+          <p:cNvPicPr>
+            <a:picLocks noChangeAspect="1"/>
+          </p:cNvPicPr>
+          <p:nvPr/>
+        </p:nvPicPr>
+        <p:blipFill>
+          <a:blip r:embed="rId2"/>
+          <a:stretch>
+            <a:fillRect/>
+          </a:stretch>
+        </p:blipFill>
+        <p:spPr>
+          <a:xfrm>
+            <a:off x="108000" y="756000"/>
+            <a:ext cx="11952000" cy="5580000"/>
+          </a:xfrm>
+          <a:prstGeom prst="rect">
+            <a:avLst/>
+          </a:prstGeom>
+        </p:spPr>
+      </p:pic>
+      <p:sp>
+        <p:nvSpPr>
+          <p:cNvPr id="7" name="Rectangle 6"/>
+          <p:cNvSpPr/>
+          <p:nvPr/>
+        </p:nvSpPr>
+        <p:spPr>
+          <a:xfrm>
+            <a:off x="0" y="6372000"/>
+            <a:ext cx="12189600" cy="486000"/>
+          </a:xfrm>
+          <a:prstGeom prst="rect">
+            <a:avLst/>
+          </a:prstGeom>
+          <a:solidFill>
+            <a:srgbClr val="20272B"/>
+          </a:solidFill>
+          <a:ln w="15240">
+            <a:solidFill>
+              <a:srgbClr val="FF8C42"/>
+            </a:solidFill>
+          </a:ln>
+        </p:spPr>
+        <p:style>
+          <a:lnRef idx="1">
+            <a:schemeClr val="accent1"/>
+          </a:lnRef>
+          <a:fillRef idx="3">
+            <a:schemeClr val="accent1"/>
+          </a:fillRef>
+          <a:effectRef idx="2">
+            <a:schemeClr val="accent1"/>
+          </a:effectRef>
+          <a:fontRef idx="minor">
+            <a:schemeClr val="lt1"/>
+          </a:fontRef>
+        </p:style>
+        <p:txBody>
+          <a:bodyPr rtlCol="0" anchor="ctr"/>
+          <a:lstStyle/>
+          <a:p>
+            <a:pPr algn="ctr"/>
+          </a:p>
+        </p:txBody>
+      </p:sp>
+      <p:sp>
+        <p:nvSpPr>
+          <p:cNvPr id="8" name="TextBox 7"/>
+          <p:cNvSpPr txBox="1"/>
+          <p:nvPr/>
+        </p:nvSpPr>
+        <p:spPr>
+          <a:xfrm>
+            <a:off x="180000" y="6390000"/>
+            <a:ext cx="11700000" cy="450000"/>
+          </a:xfrm>
+          <a:prstGeom prst="rect">
+            <a:avLst/>
+          </a:prstGeom>
+          <a:noFill/>
+        </p:spPr>
+        <p:txBody>
+          <a:bodyPr wrap="square">
+            <a:spAutoFit/>
+          </a:bodyPr>
+          <a:lstStyle/>
+          <a:p>
+            <a:pPr algn="l"/>
+            <a:r>
+              <a:rPr sz="1000" b="1" i="0">
+                <a:solidFill>
+                  <a:srgbClr val="FF8C42"/>
+                </a:solidFill>
+              </a:rPr>
+              <a:t>ВЫВОД: В-банк горячее А-банка на 25°C в среднем. Цил.2 достигает 521°C — ВНИМАНИЕ.</a:t>
+            </a:r>
+          </a:p>
+        </p:txBody>
+      </p:sp>
+    </p:spTree>
+  </p:cSld>
+  <p:clrMapOvr>
+    <a:masterClrMapping/>
+  </p:clrMapOvr>
+</p:sld>
+</file>
+
+<file path=ppt/slides/slide16.xml><?xml version="1.0" encoding="utf-8"?>
+<p:sld xmlns:a="http://schemas.openxmlformats.org/drawingml/2006/main" xmlns:p="http://schemas.openxmlformats.org/presentationml/2006/main" xmlns:r="http://schemas.openxmlformats.org/officeDocument/2006/relationships">
+  <p:cSld>
+    <p:bg>
+      <p:bgPr>
+        <a:solidFill>
+          <a:srgbClr val="293136"/>
+        </a:solidFill>
+        <a:effectLst/>
+      </p:bgPr>
+    </p:bg>
+    <p:spTree>
+      <p:nvGrpSpPr>
+        <p:cNvPr id="1" name=""/>
+        <p:cNvGrpSpPr/>
+        <p:nvPr/>
+      </p:nvGrpSpPr>
+      <p:grpSpPr/>
+      <p:sp>
+        <p:nvSpPr>
+          <p:cNvPr id="2" name="Rectangle 1"/>
+          <p:cNvSpPr/>
+          <p:nvPr/>
+        </p:nvSpPr>
+        <p:spPr>
+          <a:xfrm>
+            <a:off x="0" y="0"/>
+            <a:ext cx="12189600" cy="720000"/>
+          </a:xfrm>
+          <a:prstGeom prst="rect">
+            <a:avLst/>
+          </a:prstGeom>
+          <a:solidFill>
+            <a:srgbClr val="20272B"/>
+          </a:solidFill>
+          <a:ln>
+            <a:noFill/>
+          </a:ln>
+        </p:spPr>
+        <p:style>
+          <a:lnRef idx="1">
+            <a:schemeClr val="accent1"/>
+          </a:lnRef>
+          <a:fillRef idx="3">
+            <a:schemeClr val="accent1"/>
+          </a:fillRef>
+          <a:effectRef idx="2">
+            <a:schemeClr val="accent1"/>
+          </a:effectRef>
+          <a:fontRef idx="minor">
+            <a:schemeClr val="lt1"/>
+          </a:fontRef>
+        </p:style>
+        <p:txBody>
+          <a:bodyPr rtlCol="0" anchor="ctr"/>
+          <a:lstStyle/>
+          <a:p>
+            <a:pPr algn="ctr"/>
+          </a:p>
+        </p:txBody>
+      </p:sp>
+      <p:sp>
+        <p:nvSpPr>
+          <p:cNvPr id="3" name="Rectangle 2"/>
+          <p:cNvSpPr/>
+          <p:nvPr/>
+        </p:nvSpPr>
+        <p:spPr>
+          <a:xfrm>
+            <a:off x="0" y="666000"/>
+            <a:ext cx="12189600" cy="43200"/>
+          </a:xfrm>
+          <a:prstGeom prst="rect">
+            <a:avLst/>
+          </a:prstGeom>
+          <a:solidFill>
+            <a:srgbClr val="3EF0AF"/>
+          </a:solidFill>
+          <a:ln>
+            <a:noFill/>
+          </a:ln>
+        </p:spPr>
+        <p:style>
+          <a:lnRef idx="1">
+            <a:schemeClr val="accent1"/>
+          </a:lnRef>
+          <a:fillRef idx="3">
+            <a:schemeClr val="accent1"/>
+          </a:fillRef>
+          <a:effectRef idx="2">
+            <a:schemeClr val="accent1"/>
+          </a:effectRef>
+          <a:fontRef idx="minor">
+            <a:schemeClr val="lt1"/>
+          </a:fontRef>
+        </p:style>
+        <p:txBody>
+          <a:bodyPr rtlCol="0" anchor="ctr"/>
+          <a:lstStyle/>
+          <a:p>
+            <a:pPr algn="ctr"/>
+          </a:p>
+        </p:txBody>
+      </p:sp>
+      <p:sp>
+        <p:nvSpPr>
+          <p:cNvPr id="4" name="TextBox 3"/>
+          <p:cNvSpPr txBox="1"/>
+          <p:nvPr/>
+        </p:nvSpPr>
+        <p:spPr>
+          <a:xfrm>
+            <a:off x="180000" y="36000"/>
+            <a:ext cx="11520000" cy="396000"/>
+          </a:xfrm>
+          <a:prstGeom prst="rect">
+            <a:avLst/>
+          </a:prstGeom>
+          <a:noFill/>
+        </p:spPr>
+        <p:txBody>
+          <a:bodyPr wrap="square">
+            <a:spAutoFit/>
+          </a:bodyPr>
+          <a:lstStyle/>
+          <a:p>
+            <a:pPr algn="l"/>
+            <a:r>
+              <a:rPr sz="1600" b="1" i="0">
+                <a:solidFill>
+                  <a:srgbClr val="FFFFFF"/>
+                </a:solidFill>
+              </a:rPr>
+              <a:t>ТЕМПЕРАТУРА ЦИЛИНДРОВ — АГРЕГАТ #50  |  19.05.2026</a:t>
+            </a:r>
+          </a:p>
+        </p:txBody>
+      </p:sp>
+      <p:sp>
+        <p:nvSpPr>
+          <p:cNvPr id="5" name="TextBox 4"/>
+          <p:cNvSpPr txBox="1"/>
+          <p:nvPr/>
+        </p:nvSpPr>
+        <p:spPr>
+          <a:xfrm>
+            <a:off x="180000" y="432000"/>
+            <a:ext cx="11520000" cy="234000"/>
+          </a:xfrm>
+          <a:prstGeom prst="rect">
+            <a:avLst/>
+          </a:prstGeom>
+          <a:noFill/>
+        </p:spPr>
+        <p:txBody>
+          <a:bodyPr wrap="square">
+            <a:spAutoFit/>
+          </a:bodyPr>
+          <a:lstStyle/>
+          <a:p>
+            <a:pPr algn="l"/>
+            <a:r>
+              <a:rPr sz="950" b="0" i="0">
+                <a:solidFill>
+                  <a:srgbClr val="667788"/>
+                </a:solidFill>
+              </a:rPr>
+              <a:t>А-банк (нечётные, ECM144) — В-банк (чётные, ECM1)  |  Индивидуальные ЕГТ по цилиндрам</a:t>
+            </a:r>
+          </a:p>
+        </p:txBody>
+      </p:sp>
+      <p:pic>
+        <p:nvPicPr>
+          <p:cNvPr id="6" name="Picture 5" descr="tmpwh9etp7z.png"/>
+          <p:cNvPicPr>
+            <a:picLocks noChangeAspect="1"/>
+          </p:cNvPicPr>
+          <p:nvPr/>
+        </p:nvPicPr>
+        <p:blipFill>
+          <a:blip r:embed="rId2"/>
+          <a:stretch>
+            <a:fillRect/>
+          </a:stretch>
+        </p:blipFill>
+        <p:spPr>
+          <a:xfrm>
+            <a:off x="108000" y="756000"/>
+            <a:ext cx="11952000" cy="5580000"/>
+          </a:xfrm>
+          <a:prstGeom prst="rect">
+            <a:avLst/>
+          </a:prstGeom>
+        </p:spPr>
+      </p:pic>
+      <p:sp>
+        <p:nvSpPr>
+          <p:cNvPr id="7" name="Rectangle 6"/>
+          <p:cNvSpPr/>
+          <p:nvPr/>
+        </p:nvSpPr>
+        <p:spPr>
+          <a:xfrm>
+            <a:off x="0" y="6372000"/>
+            <a:ext cx="12189600" cy="486000"/>
+          </a:xfrm>
+          <a:prstGeom prst="rect">
+            <a:avLst/>
+          </a:prstGeom>
+          <a:solidFill>
+            <a:srgbClr val="20272B"/>
+          </a:solidFill>
+          <a:ln w="15240">
+            <a:solidFill>
+              <a:srgbClr val="FF8C42"/>
+            </a:solidFill>
+          </a:ln>
+        </p:spPr>
+        <p:style>
+          <a:lnRef idx="1">
+            <a:schemeClr val="accent1"/>
+          </a:lnRef>
+          <a:fillRef idx="3">
+            <a:schemeClr val="accent1"/>
+          </a:fillRef>
+          <a:effectRef idx="2">
+            <a:schemeClr val="accent1"/>
+          </a:effectRef>
+          <a:fontRef idx="minor">
+            <a:schemeClr val="lt1"/>
+          </a:fontRef>
+        </p:style>
+        <p:txBody>
+          <a:bodyPr rtlCol="0" anchor="ctr"/>
+          <a:lstStyle/>
+          <a:p>
+            <a:pPr algn="ctr"/>
+          </a:p>
+        </p:txBody>
+      </p:sp>
+      <p:sp>
+        <p:nvSpPr>
+          <p:cNvPr id="8" name="TextBox 7"/>
+          <p:cNvSpPr txBox="1"/>
+          <p:nvPr/>
+        </p:nvSpPr>
+        <p:spPr>
+          <a:xfrm>
+            <a:off x="180000" y="6390000"/>
+            <a:ext cx="11700000" cy="450000"/>
+          </a:xfrm>
+          <a:prstGeom prst="rect">
+            <a:avLst/>
+          </a:prstGeom>
+          <a:noFill/>
+        </p:spPr>
+        <p:txBody>
+          <a:bodyPr wrap="square">
+            <a:spAutoFit/>
+          </a:bodyPr>
+          <a:lstStyle/>
+          <a:p>
+            <a:pPr algn="l"/>
+            <a:r>
+              <a:rPr sz="1000" b="1" i="0">
+                <a:solidFill>
+                  <a:srgbClr val="FF8C42"/>
+                </a:solidFill>
+              </a:rPr>
+              <a:t>ВЫВОД: В-банк горячее А-банка на 13°C в среднем. Цил.10 достигает 556°C — КРИТИЧНО.</a:t>
+            </a:r>
+          </a:p>
+        </p:txBody>
+      </p:sp>
+    </p:spTree>
+  </p:cSld>
+  <p:clrMapOvr>
+    <a:masterClrMapping/>
+  </p:clrMapOvr>
+</p:sld>
+</file>
+
+<file path=ppt/slides/slide17.xml><?xml version="1.0" encoding="utf-8"?>
+<p:sld xmlns:a="http://schemas.openxmlformats.org/drawingml/2006/main" xmlns:p="http://schemas.openxmlformats.org/presentationml/2006/main" xmlns:r="http://schemas.openxmlformats.org/officeDocument/2006/relationships">
+  <p:cSld>
+    <p:bg>
+      <p:bgPr>
+        <a:solidFill>
+          <a:srgbClr val="293136"/>
+        </a:solidFill>
+        <a:effectLst/>
+      </p:bgPr>
+    </p:bg>
+    <p:spTree>
+      <p:nvGrpSpPr>
+        <p:cNvPr id="1" name=""/>
+        <p:cNvGrpSpPr/>
+        <p:nvPr/>
+      </p:nvGrpSpPr>
+      <p:grpSpPr/>
+      <p:sp>
+        <p:nvSpPr>
+          <p:cNvPr id="2" name="Rectangle 1"/>
+          <p:cNvSpPr/>
+          <p:nvPr/>
+        </p:nvSpPr>
+        <p:spPr>
+          <a:xfrm>
+            <a:off x="0" y="0"/>
+            <a:ext cx="12189600" cy="720000"/>
+          </a:xfrm>
+          <a:prstGeom prst="rect">
+            <a:avLst/>
+          </a:prstGeom>
+          <a:solidFill>
+            <a:srgbClr val="20272B"/>
+          </a:solidFill>
+          <a:ln>
+            <a:noFill/>
+          </a:ln>
+        </p:spPr>
+        <p:style>
+          <a:lnRef idx="1">
+            <a:schemeClr val="accent1"/>
+          </a:lnRef>
+          <a:fillRef idx="3">
+            <a:schemeClr val="accent1"/>
+          </a:fillRef>
+          <a:effectRef idx="2">
+            <a:schemeClr val="accent1"/>
+          </a:effectRef>
+          <a:fontRef idx="minor">
+            <a:schemeClr val="lt1"/>
+          </a:fontRef>
+        </p:style>
+        <p:txBody>
+          <a:bodyPr rtlCol="0" anchor="ctr"/>
+          <a:lstStyle/>
+          <a:p>
+            <a:pPr algn="ctr"/>
+          </a:p>
+        </p:txBody>
+      </p:sp>
+      <p:sp>
+        <p:nvSpPr>
+          <p:cNvPr id="3" name="Rectangle 2"/>
+          <p:cNvSpPr/>
+          <p:nvPr/>
+        </p:nvSpPr>
+        <p:spPr>
+          <a:xfrm>
+            <a:off x="0" y="666000"/>
+            <a:ext cx="12189600" cy="43200"/>
+          </a:xfrm>
+          <a:prstGeom prst="rect">
+            <a:avLst/>
+          </a:prstGeom>
+          <a:solidFill>
+            <a:srgbClr val="3EF0AF"/>
+          </a:solidFill>
+          <a:ln>
+            <a:noFill/>
+          </a:ln>
+        </p:spPr>
+        <p:style>
+          <a:lnRef idx="1">
+            <a:schemeClr val="accent1"/>
+          </a:lnRef>
+          <a:fillRef idx="3">
+            <a:schemeClr val="accent1"/>
+          </a:fillRef>
+          <a:effectRef idx="2">
+            <a:schemeClr val="accent1"/>
+          </a:effectRef>
+          <a:fontRef idx="minor">
+            <a:schemeClr val="lt1"/>
+          </a:fontRef>
+        </p:style>
+        <p:txBody>
+          <a:bodyPr rtlCol="0" anchor="ctr"/>
+          <a:lstStyle/>
+          <a:p>
+            <a:pPr algn="ctr"/>
+          </a:p>
+        </p:txBody>
+      </p:sp>
+      <p:sp>
+        <p:nvSpPr>
+          <p:cNvPr id="4" name="TextBox 3"/>
+          <p:cNvSpPr txBox="1"/>
+          <p:nvPr/>
+        </p:nvSpPr>
+        <p:spPr>
+          <a:xfrm>
+            <a:off x="180000" y="36000"/>
+            <a:ext cx="11520000" cy="396000"/>
+          </a:xfrm>
+          <a:prstGeom prst="rect">
+            <a:avLst/>
+          </a:prstGeom>
+          <a:noFill/>
+        </p:spPr>
+        <p:txBody>
+          <a:bodyPr wrap="square">
+            <a:spAutoFit/>
+          </a:bodyPr>
+          <a:lstStyle/>
+          <a:p>
+            <a:pPr algn="l"/>
+            <a:r>
+              <a:rPr sz="1600" b="1" i="0">
+                <a:solidFill>
+                  <a:srgbClr val="FFFFFF"/>
+                </a:solidFill>
+              </a:rPr>
+              <a:t>ТЕМПЕРАТУРА ЦИЛИНДРОВ — АГРЕГАТ #52  |  18.05.2026</a:t>
+            </a:r>
+          </a:p>
+        </p:txBody>
+      </p:sp>
+      <p:sp>
+        <p:nvSpPr>
+          <p:cNvPr id="5" name="TextBox 4"/>
+          <p:cNvSpPr txBox="1"/>
+          <p:nvPr/>
+        </p:nvSpPr>
+        <p:spPr>
+          <a:xfrm>
+            <a:off x="180000" y="432000"/>
+            <a:ext cx="11520000" cy="234000"/>
+          </a:xfrm>
+          <a:prstGeom prst="rect">
+            <a:avLst/>
+          </a:prstGeom>
+          <a:noFill/>
+        </p:spPr>
+        <p:txBody>
+          <a:bodyPr wrap="square">
+            <a:spAutoFit/>
+          </a:bodyPr>
+          <a:lstStyle/>
+          <a:p>
+            <a:pPr algn="l"/>
+            <a:r>
+              <a:rPr sz="950" b="0" i="0">
+                <a:solidFill>
+                  <a:srgbClr val="667788"/>
+                </a:solidFill>
+              </a:rPr>
+              <a:t>А-банк (нечётные, ECM144) — В-банк (чётные, ECM1)  |  Индивидуальные ЕГТ по цилиндрам</a:t>
+            </a:r>
+          </a:p>
+        </p:txBody>
+      </p:sp>
+      <p:pic>
+        <p:nvPicPr>
+          <p:cNvPr id="6" name="Picture 5" descr="tmpmojc_8lp.png"/>
+          <p:cNvPicPr>
+            <a:picLocks noChangeAspect="1"/>
+          </p:cNvPicPr>
+          <p:nvPr/>
+        </p:nvPicPr>
+        <p:blipFill>
+          <a:blip r:embed="rId2"/>
+          <a:stretch>
+            <a:fillRect/>
+          </a:stretch>
+        </p:blipFill>
+        <p:spPr>
+          <a:xfrm>
+            <a:off x="108000" y="756000"/>
+            <a:ext cx="11952000" cy="5580000"/>
+          </a:xfrm>
+          <a:prstGeom prst="rect">
+            <a:avLst/>
+          </a:prstGeom>
+        </p:spPr>
+      </p:pic>
+      <p:sp>
+        <p:nvSpPr>
+          <p:cNvPr id="7" name="Rectangle 6"/>
+          <p:cNvSpPr/>
+          <p:nvPr/>
+        </p:nvSpPr>
+        <p:spPr>
+          <a:xfrm>
+            <a:off x="0" y="6372000"/>
+            <a:ext cx="12189600" cy="486000"/>
+          </a:xfrm>
+          <a:prstGeom prst="rect">
+            <a:avLst/>
+          </a:prstGeom>
+          <a:solidFill>
+            <a:srgbClr val="20272B"/>
+          </a:solidFill>
+          <a:ln w="15240">
+            <a:solidFill>
+              <a:srgbClr val="FF8C42"/>
+            </a:solidFill>
+          </a:ln>
+        </p:spPr>
+        <p:style>
+          <a:lnRef idx="1">
+            <a:schemeClr val="accent1"/>
+          </a:lnRef>
+          <a:fillRef idx="3">
+            <a:schemeClr val="accent1"/>
+          </a:fillRef>
+          <a:effectRef idx="2">
+            <a:schemeClr val="accent1"/>
+          </a:effectRef>
+          <a:fontRef idx="minor">
+            <a:schemeClr val="lt1"/>
+          </a:fontRef>
+        </p:style>
+        <p:txBody>
+          <a:bodyPr rtlCol="0" anchor="ctr"/>
+          <a:lstStyle/>
+          <a:p>
+            <a:pPr algn="ctr"/>
+          </a:p>
+        </p:txBody>
+      </p:sp>
+      <p:sp>
+        <p:nvSpPr>
+          <p:cNvPr id="8" name="TextBox 7"/>
+          <p:cNvSpPr txBox="1"/>
+          <p:nvPr/>
+        </p:nvSpPr>
+        <p:spPr>
+          <a:xfrm>
+            <a:off x="180000" y="6390000"/>
+            <a:ext cx="11700000" cy="450000"/>
+          </a:xfrm>
+          <a:prstGeom prst="rect">
+            <a:avLst/>
+          </a:prstGeom>
+          <a:noFill/>
+        </p:spPr>
+        <p:txBody>
+          <a:bodyPr wrap="square">
+            <a:spAutoFit/>
+          </a:bodyPr>
+          <a:lstStyle/>
+          <a:p>
+            <a:pPr algn="l"/>
+            <a:r>
+              <a:rPr sz="1000" b="1" i="0">
+                <a:solidFill>
+                  <a:srgbClr val="FF8C42"/>
+                </a:solidFill>
+              </a:rPr>
+              <a:t>ВЫВОД: А-банк горячее В-банка на 16°C в среднем. Цил.12 достигает 526°C — ВНИМАНИЕ.</a:t>
+            </a:r>
+          </a:p>
+        </p:txBody>
+      </p:sp>
+    </p:spTree>
+  </p:cSld>
+  <p:clrMapOvr>
+    <a:masterClrMapping/>
+  </p:clrMapOvr>
+</p:sld>
+</file>
+
+<file path=ppt/slides/slide18.xml><?xml version="1.0" encoding="utf-8"?>
+<p:sld xmlns:a="http://schemas.openxmlformats.org/drawingml/2006/main" xmlns:p="http://schemas.openxmlformats.org/presentationml/2006/main" xmlns:r="http://schemas.openxmlformats.org/officeDocument/2006/relationships">
+  <p:cSld>
+    <p:bg>
+      <p:bgPr>
+        <a:solidFill>
+          <a:srgbClr val="293136"/>
+        </a:solidFill>
+        <a:effectLst/>
+      </p:bgPr>
+    </p:bg>
+    <p:spTree>
+      <p:nvGrpSpPr>
+        <p:cNvPr id="1" name=""/>
+        <p:cNvGrpSpPr/>
+        <p:nvPr/>
+      </p:nvGrpSpPr>
+      <p:grpSpPr/>
+      <p:sp>
+        <p:nvSpPr>
+          <p:cNvPr id="2" name="Rectangle 1"/>
+          <p:cNvSpPr/>
+          <p:nvPr/>
+        </p:nvSpPr>
+        <p:spPr>
+          <a:xfrm>
+            <a:off x="0" y="0"/>
+            <a:ext cx="12189600" cy="720000"/>
+          </a:xfrm>
+          <a:prstGeom prst="rect">
+            <a:avLst/>
+          </a:prstGeom>
+          <a:solidFill>
+            <a:srgbClr val="20272B"/>
+          </a:solidFill>
+          <a:ln>
+            <a:noFill/>
+          </a:ln>
+        </p:spPr>
+        <p:style>
+          <a:lnRef idx="1">
+            <a:schemeClr val="accent1"/>
+          </a:lnRef>
+          <a:fillRef idx="3">
+            <a:schemeClr val="accent1"/>
+          </a:fillRef>
+          <a:effectRef idx="2">
+            <a:schemeClr val="accent1"/>
+          </a:effectRef>
+          <a:fontRef idx="minor">
+            <a:schemeClr val="lt1"/>
+          </a:fontRef>
+        </p:style>
+        <p:txBody>
+          <a:bodyPr rtlCol="0" anchor="ctr"/>
+          <a:lstStyle/>
+          <a:p>
+            <a:pPr algn="ctr"/>
+          </a:p>
+        </p:txBody>
+      </p:sp>
+      <p:sp>
+        <p:nvSpPr>
+          <p:cNvPr id="3" name="Rectangle 2"/>
+          <p:cNvSpPr/>
+          <p:nvPr/>
+        </p:nvSpPr>
+        <p:spPr>
+          <a:xfrm>
+            <a:off x="0" y="666000"/>
+            <a:ext cx="12189600" cy="43200"/>
+          </a:xfrm>
+          <a:prstGeom prst="rect">
+            <a:avLst/>
+          </a:prstGeom>
+          <a:solidFill>
+            <a:srgbClr val="3EF0AF"/>
+          </a:solidFill>
+          <a:ln>
+            <a:noFill/>
+          </a:ln>
+        </p:spPr>
+        <p:style>
+          <a:lnRef idx="1">
+            <a:schemeClr val="accent1"/>
+          </a:lnRef>
+          <a:fillRef idx="3">
+            <a:schemeClr val="accent1"/>
+          </a:fillRef>
+          <a:effectRef idx="2">
+            <a:schemeClr val="accent1"/>
+          </a:effectRef>
+          <a:fontRef idx="minor">
+            <a:schemeClr val="lt1"/>
+          </a:fontRef>
+        </p:style>
+        <p:txBody>
+          <a:bodyPr rtlCol="0" anchor="ctr"/>
+          <a:lstStyle/>
+          <a:p>
+            <a:pPr algn="ctr"/>
+          </a:p>
+        </p:txBody>
+      </p:sp>
+      <p:sp>
+        <p:nvSpPr>
+          <p:cNvPr id="4" name="TextBox 3"/>
+          <p:cNvSpPr txBox="1"/>
+          <p:nvPr/>
+        </p:nvSpPr>
+        <p:spPr>
+          <a:xfrm>
+            <a:off x="180000" y="36000"/>
+            <a:ext cx="11520000" cy="396000"/>
+          </a:xfrm>
+          <a:prstGeom prst="rect">
+            <a:avLst/>
+          </a:prstGeom>
+          <a:noFill/>
+        </p:spPr>
+        <p:txBody>
+          <a:bodyPr wrap="square">
+            <a:spAutoFit/>
+          </a:bodyPr>
+          <a:lstStyle/>
+          <a:p>
+            <a:pPr algn="l"/>
+            <a:r>
+              <a:rPr sz="1600" b="1" i="0">
+                <a:solidFill>
+                  <a:srgbClr val="FFFFFF"/>
+                </a:solidFill>
+              </a:rPr>
+              <a:t>ТЕМПЕРАТУРА ЦИЛИНДРОВ — АГРЕГАТ #56  |  19.05.2026</a:t>
+            </a:r>
+          </a:p>
+        </p:txBody>
+      </p:sp>
+      <p:sp>
+        <p:nvSpPr>
+          <p:cNvPr id="5" name="TextBox 4"/>
+          <p:cNvSpPr txBox="1"/>
+          <p:nvPr/>
+        </p:nvSpPr>
+        <p:spPr>
+          <a:xfrm>
+            <a:off x="180000" y="432000"/>
+            <a:ext cx="11520000" cy="234000"/>
+          </a:xfrm>
+          <a:prstGeom prst="rect">
+            <a:avLst/>
+          </a:prstGeom>
+          <a:noFill/>
+        </p:spPr>
+        <p:txBody>
+          <a:bodyPr wrap="square">
+            <a:spAutoFit/>
+          </a:bodyPr>
+          <a:lstStyle/>
+          <a:p>
+            <a:pPr algn="l"/>
+            <a:r>
+              <a:rPr sz="950" b="0" i="0">
+                <a:solidFill>
+                  <a:srgbClr val="667788"/>
+                </a:solidFill>
+              </a:rPr>
+              <a:t>А-банк (нечётные, ECM144) — В-банк (чётные, ECM1)  |  Индивидуальные ЕГТ по цилиндрам</a:t>
+            </a:r>
+          </a:p>
+        </p:txBody>
+      </p:sp>
+      <p:pic>
+        <p:nvPicPr>
+          <p:cNvPr id="6" name="Picture 5" descr="tmpx1oigkcp.png"/>
+          <p:cNvPicPr>
+            <a:picLocks noChangeAspect="1"/>
+          </p:cNvPicPr>
+          <p:nvPr/>
+        </p:nvPicPr>
+        <p:blipFill>
+          <a:blip r:embed="rId2"/>
+          <a:stretch>
+            <a:fillRect/>
+          </a:stretch>
+        </p:blipFill>
+        <p:spPr>
+          <a:xfrm>
+            <a:off x="108000" y="756000"/>
+            <a:ext cx="11952000" cy="5580000"/>
+          </a:xfrm>
+          <a:prstGeom prst="rect">
+            <a:avLst/>
+          </a:prstGeom>
+        </p:spPr>
+      </p:pic>
+      <p:sp>
+        <p:nvSpPr>
+          <p:cNvPr id="7" name="Rectangle 6"/>
+          <p:cNvSpPr/>
+          <p:nvPr/>
+        </p:nvSpPr>
+        <p:spPr>
+          <a:xfrm>
+            <a:off x="0" y="6372000"/>
+            <a:ext cx="12189600" cy="486000"/>
+          </a:xfrm>
+          <a:prstGeom prst="rect">
+            <a:avLst/>
+          </a:prstGeom>
+          <a:solidFill>
+            <a:srgbClr val="20272B"/>
+          </a:solidFill>
+          <a:ln w="15240">
+            <a:solidFill>
+              <a:srgbClr val="FF8C42"/>
+            </a:solidFill>
+          </a:ln>
+        </p:spPr>
+        <p:style>
+          <a:lnRef idx="1">
+            <a:schemeClr val="accent1"/>
+          </a:lnRef>
+          <a:fillRef idx="3">
+            <a:schemeClr val="accent1"/>
+          </a:fillRef>
+          <a:effectRef idx="2">
+            <a:schemeClr val="accent1"/>
+          </a:effectRef>
+          <a:fontRef idx="minor">
+            <a:schemeClr val="lt1"/>
+          </a:fontRef>
+        </p:style>
+        <p:txBody>
+          <a:bodyPr rtlCol="0" anchor="ctr"/>
+          <a:lstStyle/>
+          <a:p>
+            <a:pPr algn="ctr"/>
+          </a:p>
+        </p:txBody>
+      </p:sp>
+      <p:sp>
+        <p:nvSpPr>
+          <p:cNvPr id="8" name="TextBox 7"/>
+          <p:cNvSpPr txBox="1"/>
+          <p:nvPr/>
+        </p:nvSpPr>
+        <p:spPr>
+          <a:xfrm>
+            <a:off x="180000" y="6390000"/>
+            <a:ext cx="11700000" cy="450000"/>
+          </a:xfrm>
+          <a:prstGeom prst="rect">
+            <a:avLst/>
+          </a:prstGeom>
+          <a:noFill/>
+        </p:spPr>
+        <p:txBody>
+          <a:bodyPr wrap="square">
+            <a:spAutoFit/>
+          </a:bodyPr>
+          <a:lstStyle/>
+          <a:p>
+            <a:pPr algn="l"/>
+            <a:r>
+              <a:rPr sz="1000" b="1" i="0">
+                <a:solidFill>
+                  <a:srgbClr val="FF8C42"/>
+                </a:solidFill>
+              </a:rPr>
+              <a:t>ВЫВОД: А-банк горячее В-банка на 17°C в среднем. Цил.11 достигает 546°C — ВНИМАНИЕ.</a:t>
+            </a:r>
+          </a:p>
+        </p:txBody>
+      </p:sp>
+    </p:spTree>
+  </p:cSld>
+  <p:clrMapOvr>
+    <a:masterClrMapping/>
+  </p:clrMapOvr>
+</p:sld>
+</file>
+
+<file path=ppt/slides/slide19.xml><?xml version="1.0" encoding="utf-8"?>
+<p:sld xmlns:a="http://schemas.openxmlformats.org/drawingml/2006/main" xmlns:p="http://schemas.openxmlformats.org/presentationml/2006/main" xmlns:r="http://schemas.openxmlformats.org/officeDocument/2006/relationships">
+  <p:cSld>
+    <p:bg>
+      <p:bgPr>
+        <a:solidFill>
+          <a:srgbClr val="293136"/>
+        </a:solidFill>
+        <a:effectLst/>
+      </p:bgPr>
+    </p:bg>
+    <p:spTree>
+      <p:nvGrpSpPr>
+        <p:cNvPr id="1" name=""/>
+        <p:cNvGrpSpPr/>
+        <p:nvPr/>
+      </p:nvGrpSpPr>
+      <p:grpSpPr/>
+      <p:sp>
+        <p:nvSpPr>
+          <p:cNvPr id="2" name="Rectangle 1"/>
+          <p:cNvSpPr/>
+          <p:nvPr/>
+        </p:nvSpPr>
+        <p:spPr>
+          <a:xfrm>
+            <a:off x="0" y="0"/>
+            <a:ext cx="12189600" cy="720000"/>
+          </a:xfrm>
+          <a:prstGeom prst="rect">
+            <a:avLst/>
+          </a:prstGeom>
+          <a:solidFill>
+            <a:srgbClr val="20272B"/>
+          </a:solidFill>
+          <a:ln>
+            <a:noFill/>
+          </a:ln>
+        </p:spPr>
+        <p:style>
+          <a:lnRef idx="1">
+            <a:schemeClr val="accent1"/>
+          </a:lnRef>
+          <a:fillRef idx="3">
+            <a:schemeClr val="accent1"/>
+          </a:fillRef>
+          <a:effectRef idx="2">
+            <a:schemeClr val="accent1"/>
+          </a:effectRef>
+          <a:fontRef idx="minor">
+            <a:schemeClr val="lt1"/>
+          </a:fontRef>
+        </p:style>
+        <p:txBody>
+          <a:bodyPr rtlCol="0" anchor="ctr"/>
+          <a:lstStyle/>
+          <a:p>
+            <a:pPr algn="ctr"/>
+          </a:p>
+        </p:txBody>
+      </p:sp>
+      <p:sp>
+        <p:nvSpPr>
+          <p:cNvPr id="3" name="Rectangle 2"/>
+          <p:cNvSpPr/>
+          <p:nvPr/>
+        </p:nvSpPr>
+        <p:spPr>
+          <a:xfrm>
+            <a:off x="0" y="666000"/>
+            <a:ext cx="12189600" cy="43200"/>
+          </a:xfrm>
+          <a:prstGeom prst="rect">
+            <a:avLst/>
+          </a:prstGeom>
+          <a:solidFill>
+            <a:srgbClr val="3EF0AF"/>
+          </a:solidFill>
+          <a:ln>
+            <a:noFill/>
+          </a:ln>
+        </p:spPr>
+        <p:style>
+          <a:lnRef idx="1">
+            <a:schemeClr val="accent1"/>
+          </a:lnRef>
+          <a:fillRef idx="3">
+            <a:schemeClr val="accent1"/>
+          </a:fillRef>
+          <a:effectRef idx="2">
+            <a:schemeClr val="accent1"/>
+          </a:effectRef>
+          <a:fontRef idx="minor">
+            <a:schemeClr val="lt1"/>
+          </a:fontRef>
+        </p:style>
+        <p:txBody>
+          <a:bodyPr rtlCol="0" anchor="ctr"/>
+          <a:lstStyle/>
+          <a:p>
+            <a:pPr algn="ctr"/>
+          </a:p>
+        </p:txBody>
+      </p:sp>
+      <p:sp>
+        <p:nvSpPr>
+          <p:cNvPr id="4" name="TextBox 3"/>
+          <p:cNvSpPr txBox="1"/>
+          <p:nvPr/>
+        </p:nvSpPr>
+        <p:spPr>
+          <a:xfrm>
+            <a:off x="180000" y="36000"/>
+            <a:ext cx="11520000" cy="396000"/>
+          </a:xfrm>
+          <a:prstGeom prst="rect">
+            <a:avLst/>
+          </a:prstGeom>
+          <a:noFill/>
+        </p:spPr>
+        <p:txBody>
+          <a:bodyPr wrap="square">
+            <a:spAutoFit/>
+          </a:bodyPr>
+          <a:lstStyle/>
+          <a:p>
+            <a:pPr algn="l"/>
+            <a:r>
+              <a:rPr sz="1600" b="1" i="0">
+                <a:solidFill>
+                  <a:srgbClr val="FFFFFF"/>
+                </a:solidFill>
+              </a:rPr>
+              <a:t>ТЕМПЕРАТУРА ЦИЛИНДРОВ — АГРЕГАТ #84 (16.05)  |  16.05.2026</a:t>
+            </a:r>
+          </a:p>
+        </p:txBody>
+      </p:sp>
+      <p:sp>
+        <p:nvSpPr>
+          <p:cNvPr id="5" name="TextBox 4"/>
+          <p:cNvSpPr txBox="1"/>
+          <p:nvPr/>
+        </p:nvSpPr>
+        <p:spPr>
+          <a:xfrm>
+            <a:off x="180000" y="432000"/>
+            <a:ext cx="11520000" cy="234000"/>
+          </a:xfrm>
+          <a:prstGeom prst="rect">
+            <a:avLst/>
+          </a:prstGeom>
+          <a:noFill/>
+        </p:spPr>
+        <p:txBody>
+          <a:bodyPr wrap="square">
+            <a:spAutoFit/>
+          </a:bodyPr>
+          <a:lstStyle/>
+          <a:p>
+            <a:pPr algn="l"/>
+            <a:r>
+              <a:rPr sz="950" b="0" i="0">
+                <a:solidFill>
+                  <a:srgbClr val="667788"/>
+                </a:solidFill>
+              </a:rPr>
+              <a:t>А-банк (нечётные, ECM144) — В-банк (чётные, ECM1)  |  Индивидуальные ЕГТ по цилиндрам</a:t>
+            </a:r>
+          </a:p>
+        </p:txBody>
+      </p:sp>
+      <p:pic>
+        <p:nvPicPr>
+          <p:cNvPr id="6" name="Picture 5" descr="tmpk5qx17f1.png"/>
+          <p:cNvPicPr>
+            <a:picLocks noChangeAspect="1"/>
+          </p:cNvPicPr>
+          <p:nvPr/>
+        </p:nvPicPr>
+        <p:blipFill>
+          <a:blip r:embed="rId2"/>
+          <a:stretch>
+            <a:fillRect/>
+          </a:stretch>
+        </p:blipFill>
+        <p:spPr>
+          <a:xfrm>
+            <a:off x="108000" y="756000"/>
+            <a:ext cx="11952000" cy="5580000"/>
+          </a:xfrm>
+          <a:prstGeom prst="rect">
+            <a:avLst/>
+          </a:prstGeom>
+        </p:spPr>
+      </p:pic>
+      <p:sp>
+        <p:nvSpPr>
+          <p:cNvPr id="7" name="Rectangle 6"/>
+          <p:cNvSpPr/>
+          <p:nvPr/>
+        </p:nvSpPr>
+        <p:spPr>
+          <a:xfrm>
+            <a:off x="0" y="6372000"/>
+            <a:ext cx="12189600" cy="486000"/>
+          </a:xfrm>
+          <a:prstGeom prst="rect">
+            <a:avLst/>
+          </a:prstGeom>
+          <a:solidFill>
+            <a:srgbClr val="20272B"/>
+          </a:solidFill>
+          <a:ln w="15240">
+            <a:solidFill>
+              <a:srgbClr val="FF8C42"/>
+            </a:solidFill>
+          </a:ln>
+        </p:spPr>
+        <p:style>
+          <a:lnRef idx="1">
+            <a:schemeClr val="accent1"/>
+          </a:lnRef>
+          <a:fillRef idx="3">
+            <a:schemeClr val="accent1"/>
+          </a:fillRef>
+          <a:effectRef idx="2">
+            <a:schemeClr val="accent1"/>
+          </a:effectRef>
+          <a:fontRef idx="minor">
+            <a:schemeClr val="lt1"/>
+          </a:fontRef>
+        </p:style>
+        <p:txBody>
+          <a:bodyPr rtlCol="0" anchor="ctr"/>
+          <a:lstStyle/>
+          <a:p>
+            <a:pPr algn="ctr"/>
+          </a:p>
+        </p:txBody>
+      </p:sp>
+      <p:sp>
+        <p:nvSpPr>
+          <p:cNvPr id="8" name="TextBox 7"/>
+          <p:cNvSpPr txBox="1"/>
+          <p:nvPr/>
+        </p:nvSpPr>
+        <p:spPr>
+          <a:xfrm>
+            <a:off x="180000" y="6390000"/>
+            <a:ext cx="11700000" cy="450000"/>
+          </a:xfrm>
+          <a:prstGeom prst="rect">
+            <a:avLst/>
+          </a:prstGeom>
+          <a:noFill/>
+        </p:spPr>
+        <p:txBody>
+          <a:bodyPr wrap="square">
+            <a:spAutoFit/>
+          </a:bodyPr>
+          <a:lstStyle/>
+          <a:p>
+            <a:pPr algn="l"/>
+            <a:r>
+              <a:rPr sz="1000" b="1" i="0">
+                <a:solidFill>
+                  <a:srgbClr val="FF8C42"/>
+                </a:solidFill>
+              </a:rPr>
+              <a:t>ВЫВОД: Банки температурно симметричны. Цил.6 достигает 528°C — ВНИМАНИЕ.</a:t>
+            </a:r>
+          </a:p>
+        </p:txBody>
+      </p:sp>
+    </p:spTree>
+  </p:cSld>
+  <p:clrMapOvr>
+    <a:masterClrMapping/>
+  </p:clrMapOvr>
+</p:sld>
+</file>
+
 <file path=ppt/slides/slide2.xml><?xml version="1.0" encoding="utf-8"?>
 <p:sld xmlns:a="http://schemas.openxmlformats.org/drawingml/2006/main" xmlns:p="http://schemas.openxmlformats.org/presentationml/2006/main" xmlns:r="http://schemas.openxmlformats.org/officeDocument/2006/relationships">
   <p:cSld>
@@ -13259,6 +15215,855 @@
                 <a:latin typeface="DejaVu Sans"/>
               </a:rPr>
               <a:t>102°C</a:t>
+            </a:r>
+          </a:p>
+        </p:txBody>
+      </p:sp>
+    </p:spTree>
+  </p:cSld>
+  <p:clrMapOvr>
+    <a:masterClrMapping/>
+  </p:clrMapOvr>
+</p:sld>
+</file>
+
+<file path=ppt/slides/slide20.xml><?xml version="1.0" encoding="utf-8"?>
+<p:sld xmlns:a="http://schemas.openxmlformats.org/drawingml/2006/main" xmlns:p="http://schemas.openxmlformats.org/presentationml/2006/main" xmlns:r="http://schemas.openxmlformats.org/officeDocument/2006/relationships">
+  <p:cSld>
+    <p:bg>
+      <p:bgPr>
+        <a:solidFill>
+          <a:srgbClr val="293136"/>
+        </a:solidFill>
+        <a:effectLst/>
+      </p:bgPr>
+    </p:bg>
+    <p:spTree>
+      <p:nvGrpSpPr>
+        <p:cNvPr id="1" name=""/>
+        <p:cNvGrpSpPr/>
+        <p:nvPr/>
+      </p:nvGrpSpPr>
+      <p:grpSpPr/>
+      <p:sp>
+        <p:nvSpPr>
+          <p:cNvPr id="2" name="Rectangle 1"/>
+          <p:cNvSpPr/>
+          <p:nvPr/>
+        </p:nvSpPr>
+        <p:spPr>
+          <a:xfrm>
+            <a:off x="0" y="0"/>
+            <a:ext cx="12189600" cy="720000"/>
+          </a:xfrm>
+          <a:prstGeom prst="rect">
+            <a:avLst/>
+          </a:prstGeom>
+          <a:solidFill>
+            <a:srgbClr val="20272B"/>
+          </a:solidFill>
+          <a:ln>
+            <a:noFill/>
+          </a:ln>
+        </p:spPr>
+        <p:style>
+          <a:lnRef idx="1">
+            <a:schemeClr val="accent1"/>
+          </a:lnRef>
+          <a:fillRef idx="3">
+            <a:schemeClr val="accent1"/>
+          </a:fillRef>
+          <a:effectRef idx="2">
+            <a:schemeClr val="accent1"/>
+          </a:effectRef>
+          <a:fontRef idx="minor">
+            <a:schemeClr val="lt1"/>
+          </a:fontRef>
+        </p:style>
+        <p:txBody>
+          <a:bodyPr rtlCol="0" anchor="ctr"/>
+          <a:lstStyle/>
+          <a:p>
+            <a:pPr algn="ctr"/>
+          </a:p>
+        </p:txBody>
+      </p:sp>
+      <p:sp>
+        <p:nvSpPr>
+          <p:cNvPr id="3" name="Rectangle 2"/>
+          <p:cNvSpPr/>
+          <p:nvPr/>
+        </p:nvSpPr>
+        <p:spPr>
+          <a:xfrm>
+            <a:off x="0" y="666000"/>
+            <a:ext cx="12189600" cy="43200"/>
+          </a:xfrm>
+          <a:prstGeom prst="rect">
+            <a:avLst/>
+          </a:prstGeom>
+          <a:solidFill>
+            <a:srgbClr val="3EF0AF"/>
+          </a:solidFill>
+          <a:ln>
+            <a:noFill/>
+          </a:ln>
+        </p:spPr>
+        <p:style>
+          <a:lnRef idx="1">
+            <a:schemeClr val="accent1"/>
+          </a:lnRef>
+          <a:fillRef idx="3">
+            <a:schemeClr val="accent1"/>
+          </a:fillRef>
+          <a:effectRef idx="2">
+            <a:schemeClr val="accent1"/>
+          </a:effectRef>
+          <a:fontRef idx="minor">
+            <a:schemeClr val="lt1"/>
+          </a:fontRef>
+        </p:style>
+        <p:txBody>
+          <a:bodyPr rtlCol="0" anchor="ctr"/>
+          <a:lstStyle/>
+          <a:p>
+            <a:pPr algn="ctr"/>
+          </a:p>
+        </p:txBody>
+      </p:sp>
+      <p:sp>
+        <p:nvSpPr>
+          <p:cNvPr id="4" name="TextBox 3"/>
+          <p:cNvSpPr txBox="1"/>
+          <p:nvPr/>
+        </p:nvSpPr>
+        <p:spPr>
+          <a:xfrm>
+            <a:off x="180000" y="36000"/>
+            <a:ext cx="11520000" cy="396000"/>
+          </a:xfrm>
+          <a:prstGeom prst="rect">
+            <a:avLst/>
+          </a:prstGeom>
+          <a:noFill/>
+        </p:spPr>
+        <p:txBody>
+          <a:bodyPr wrap="square">
+            <a:spAutoFit/>
+          </a:bodyPr>
+          <a:lstStyle/>
+          <a:p>
+            <a:pPr algn="l"/>
+            <a:r>
+              <a:rPr sz="1600" b="1" i="0">
+                <a:solidFill>
+                  <a:srgbClr val="FFFFFF"/>
+                </a:solidFill>
+              </a:rPr>
+              <a:t>ТЕМПЕРАТУРА ЦИЛИНДРОВ — АГРЕГАТ #84 (21.05)  |  21.05.2026</a:t>
+            </a:r>
+          </a:p>
+        </p:txBody>
+      </p:sp>
+      <p:sp>
+        <p:nvSpPr>
+          <p:cNvPr id="5" name="TextBox 4"/>
+          <p:cNvSpPr txBox="1"/>
+          <p:nvPr/>
+        </p:nvSpPr>
+        <p:spPr>
+          <a:xfrm>
+            <a:off x="180000" y="432000"/>
+            <a:ext cx="11520000" cy="234000"/>
+          </a:xfrm>
+          <a:prstGeom prst="rect">
+            <a:avLst/>
+          </a:prstGeom>
+          <a:noFill/>
+        </p:spPr>
+        <p:txBody>
+          <a:bodyPr wrap="square">
+            <a:spAutoFit/>
+          </a:bodyPr>
+          <a:lstStyle/>
+          <a:p>
+            <a:pPr algn="l"/>
+            <a:r>
+              <a:rPr sz="950" b="0" i="0">
+                <a:solidFill>
+                  <a:srgbClr val="667788"/>
+                </a:solidFill>
+              </a:rPr>
+              <a:t>А-банк (нечётные, ECM144) — В-банк (чётные, ECM1)  |  Индивидуальные ЕГТ по цилиндрам</a:t>
+            </a:r>
+          </a:p>
+        </p:txBody>
+      </p:sp>
+      <p:pic>
+        <p:nvPicPr>
+          <p:cNvPr id="6" name="Picture 5" descr="tmplfva8p4_.png"/>
+          <p:cNvPicPr>
+            <a:picLocks noChangeAspect="1"/>
+          </p:cNvPicPr>
+          <p:nvPr/>
+        </p:nvPicPr>
+        <p:blipFill>
+          <a:blip r:embed="rId2"/>
+          <a:stretch>
+            <a:fillRect/>
+          </a:stretch>
+        </p:blipFill>
+        <p:spPr>
+          <a:xfrm>
+            <a:off x="108000" y="756000"/>
+            <a:ext cx="11952000" cy="5580000"/>
+          </a:xfrm>
+          <a:prstGeom prst="rect">
+            <a:avLst/>
+          </a:prstGeom>
+        </p:spPr>
+      </p:pic>
+      <p:sp>
+        <p:nvSpPr>
+          <p:cNvPr id="7" name="Rectangle 6"/>
+          <p:cNvSpPr/>
+          <p:nvPr/>
+        </p:nvSpPr>
+        <p:spPr>
+          <a:xfrm>
+            <a:off x="0" y="6372000"/>
+            <a:ext cx="12189600" cy="486000"/>
+          </a:xfrm>
+          <a:prstGeom prst="rect">
+            <a:avLst/>
+          </a:prstGeom>
+          <a:solidFill>
+            <a:srgbClr val="20272B"/>
+          </a:solidFill>
+          <a:ln w="15240">
+            <a:solidFill>
+              <a:srgbClr val="FF8C42"/>
+            </a:solidFill>
+          </a:ln>
+        </p:spPr>
+        <p:style>
+          <a:lnRef idx="1">
+            <a:schemeClr val="accent1"/>
+          </a:lnRef>
+          <a:fillRef idx="3">
+            <a:schemeClr val="accent1"/>
+          </a:fillRef>
+          <a:effectRef idx="2">
+            <a:schemeClr val="accent1"/>
+          </a:effectRef>
+          <a:fontRef idx="minor">
+            <a:schemeClr val="lt1"/>
+          </a:fontRef>
+        </p:style>
+        <p:txBody>
+          <a:bodyPr rtlCol="0" anchor="ctr"/>
+          <a:lstStyle/>
+          <a:p>
+            <a:pPr algn="ctr"/>
+          </a:p>
+        </p:txBody>
+      </p:sp>
+      <p:sp>
+        <p:nvSpPr>
+          <p:cNvPr id="8" name="TextBox 7"/>
+          <p:cNvSpPr txBox="1"/>
+          <p:nvPr/>
+        </p:nvSpPr>
+        <p:spPr>
+          <a:xfrm>
+            <a:off x="180000" y="6390000"/>
+            <a:ext cx="11700000" cy="450000"/>
+          </a:xfrm>
+          <a:prstGeom prst="rect">
+            <a:avLst/>
+          </a:prstGeom>
+          <a:noFill/>
+        </p:spPr>
+        <p:txBody>
+          <a:bodyPr wrap="square">
+            <a:spAutoFit/>
+          </a:bodyPr>
+          <a:lstStyle/>
+          <a:p>
+            <a:pPr algn="l"/>
+            <a:r>
+              <a:rPr sz="1000" b="1" i="0">
+                <a:solidFill>
+                  <a:srgbClr val="FF8C42"/>
+                </a:solidFill>
+              </a:rPr>
+              <a:t>ВЫВОД: Банки температурно симметричны. Цил.6 достигает 538°C — ВНИМАНИЕ.</a:t>
+            </a:r>
+          </a:p>
+        </p:txBody>
+      </p:sp>
+    </p:spTree>
+  </p:cSld>
+  <p:clrMapOvr>
+    <a:masterClrMapping/>
+  </p:clrMapOvr>
+</p:sld>
+</file>
+
+<file path=ppt/slides/slide21.xml><?xml version="1.0" encoding="utf-8"?>
+<p:sld xmlns:a="http://schemas.openxmlformats.org/drawingml/2006/main" xmlns:p="http://schemas.openxmlformats.org/presentationml/2006/main" xmlns:r="http://schemas.openxmlformats.org/officeDocument/2006/relationships">
+  <p:cSld>
+    <p:bg>
+      <p:bgPr>
+        <a:solidFill>
+          <a:srgbClr val="293136"/>
+        </a:solidFill>
+        <a:effectLst/>
+      </p:bgPr>
+    </p:bg>
+    <p:spTree>
+      <p:nvGrpSpPr>
+        <p:cNvPr id="1" name=""/>
+        <p:cNvGrpSpPr/>
+        <p:nvPr/>
+      </p:nvGrpSpPr>
+      <p:grpSpPr/>
+      <p:sp>
+        <p:nvSpPr>
+          <p:cNvPr id="2" name="Rectangle 1"/>
+          <p:cNvSpPr/>
+          <p:nvPr/>
+        </p:nvSpPr>
+        <p:spPr>
+          <a:xfrm>
+            <a:off x="0" y="0"/>
+            <a:ext cx="12189600" cy="720000"/>
+          </a:xfrm>
+          <a:prstGeom prst="rect">
+            <a:avLst/>
+          </a:prstGeom>
+          <a:solidFill>
+            <a:srgbClr val="20272B"/>
+          </a:solidFill>
+          <a:ln>
+            <a:noFill/>
+          </a:ln>
+        </p:spPr>
+        <p:style>
+          <a:lnRef idx="1">
+            <a:schemeClr val="accent1"/>
+          </a:lnRef>
+          <a:fillRef idx="3">
+            <a:schemeClr val="accent1"/>
+          </a:fillRef>
+          <a:effectRef idx="2">
+            <a:schemeClr val="accent1"/>
+          </a:effectRef>
+          <a:fontRef idx="minor">
+            <a:schemeClr val="lt1"/>
+          </a:fontRef>
+        </p:style>
+        <p:txBody>
+          <a:bodyPr rtlCol="0" anchor="ctr"/>
+          <a:lstStyle/>
+          <a:p>
+            <a:pPr algn="ctr"/>
+          </a:p>
+        </p:txBody>
+      </p:sp>
+      <p:sp>
+        <p:nvSpPr>
+          <p:cNvPr id="3" name="Rectangle 2"/>
+          <p:cNvSpPr/>
+          <p:nvPr/>
+        </p:nvSpPr>
+        <p:spPr>
+          <a:xfrm>
+            <a:off x="0" y="666000"/>
+            <a:ext cx="12189600" cy="43200"/>
+          </a:xfrm>
+          <a:prstGeom prst="rect">
+            <a:avLst/>
+          </a:prstGeom>
+          <a:solidFill>
+            <a:srgbClr val="3EF0AF"/>
+          </a:solidFill>
+          <a:ln>
+            <a:noFill/>
+          </a:ln>
+        </p:spPr>
+        <p:style>
+          <a:lnRef idx="1">
+            <a:schemeClr val="accent1"/>
+          </a:lnRef>
+          <a:fillRef idx="3">
+            <a:schemeClr val="accent1"/>
+          </a:fillRef>
+          <a:effectRef idx="2">
+            <a:schemeClr val="accent1"/>
+          </a:effectRef>
+          <a:fontRef idx="minor">
+            <a:schemeClr val="lt1"/>
+          </a:fontRef>
+        </p:style>
+        <p:txBody>
+          <a:bodyPr rtlCol="0" anchor="ctr"/>
+          <a:lstStyle/>
+          <a:p>
+            <a:pPr algn="ctr"/>
+          </a:p>
+        </p:txBody>
+      </p:sp>
+      <p:sp>
+        <p:nvSpPr>
+          <p:cNvPr id="4" name="TextBox 3"/>
+          <p:cNvSpPr txBox="1"/>
+          <p:nvPr/>
+        </p:nvSpPr>
+        <p:spPr>
+          <a:xfrm>
+            <a:off x="180000" y="36000"/>
+            <a:ext cx="11520000" cy="396000"/>
+          </a:xfrm>
+          <a:prstGeom prst="rect">
+            <a:avLst/>
+          </a:prstGeom>
+          <a:noFill/>
+        </p:spPr>
+        <p:txBody>
+          <a:bodyPr wrap="square">
+            <a:spAutoFit/>
+          </a:bodyPr>
+          <a:lstStyle/>
+          <a:p>
+            <a:pPr algn="l"/>
+            <a:r>
+              <a:rPr sz="1600" b="1" i="0">
+                <a:solidFill>
+                  <a:srgbClr val="FFFFFF"/>
+                </a:solidFill>
+              </a:rPr>
+              <a:t>ТЕМПЕРАТУРА ЦИЛИНДРОВ — АГРЕГАТ #85  |  19.05.2026</a:t>
+            </a:r>
+          </a:p>
+        </p:txBody>
+      </p:sp>
+      <p:sp>
+        <p:nvSpPr>
+          <p:cNvPr id="5" name="TextBox 4"/>
+          <p:cNvSpPr txBox="1"/>
+          <p:nvPr/>
+        </p:nvSpPr>
+        <p:spPr>
+          <a:xfrm>
+            <a:off x="180000" y="432000"/>
+            <a:ext cx="11520000" cy="234000"/>
+          </a:xfrm>
+          <a:prstGeom prst="rect">
+            <a:avLst/>
+          </a:prstGeom>
+          <a:noFill/>
+        </p:spPr>
+        <p:txBody>
+          <a:bodyPr wrap="square">
+            <a:spAutoFit/>
+          </a:bodyPr>
+          <a:lstStyle/>
+          <a:p>
+            <a:pPr algn="l"/>
+            <a:r>
+              <a:rPr sz="950" b="0" i="0">
+                <a:solidFill>
+                  <a:srgbClr val="667788"/>
+                </a:solidFill>
+              </a:rPr>
+              <a:t>А-банк (нечётные, ECM144) — В-банк (чётные, ECM1)  |  Индивидуальные ЕГТ по цилиндрам</a:t>
+            </a:r>
+          </a:p>
+        </p:txBody>
+      </p:sp>
+      <p:pic>
+        <p:nvPicPr>
+          <p:cNvPr id="6" name="Picture 5" descr="tmpokyh4mcv.png"/>
+          <p:cNvPicPr>
+            <a:picLocks noChangeAspect="1"/>
+          </p:cNvPicPr>
+          <p:nvPr/>
+        </p:nvPicPr>
+        <p:blipFill>
+          <a:blip r:embed="rId2"/>
+          <a:stretch>
+            <a:fillRect/>
+          </a:stretch>
+        </p:blipFill>
+        <p:spPr>
+          <a:xfrm>
+            <a:off x="108000" y="756000"/>
+            <a:ext cx="11952000" cy="5580000"/>
+          </a:xfrm>
+          <a:prstGeom prst="rect">
+            <a:avLst/>
+          </a:prstGeom>
+        </p:spPr>
+      </p:pic>
+      <p:sp>
+        <p:nvSpPr>
+          <p:cNvPr id="7" name="Rectangle 6"/>
+          <p:cNvSpPr/>
+          <p:nvPr/>
+        </p:nvSpPr>
+        <p:spPr>
+          <a:xfrm>
+            <a:off x="0" y="6372000"/>
+            <a:ext cx="12189600" cy="486000"/>
+          </a:xfrm>
+          <a:prstGeom prst="rect">
+            <a:avLst/>
+          </a:prstGeom>
+          <a:solidFill>
+            <a:srgbClr val="20272B"/>
+          </a:solidFill>
+          <a:ln w="15240">
+            <a:solidFill>
+              <a:srgbClr val="FF8C42"/>
+            </a:solidFill>
+          </a:ln>
+        </p:spPr>
+        <p:style>
+          <a:lnRef idx="1">
+            <a:schemeClr val="accent1"/>
+          </a:lnRef>
+          <a:fillRef idx="3">
+            <a:schemeClr val="accent1"/>
+          </a:fillRef>
+          <a:effectRef idx="2">
+            <a:schemeClr val="accent1"/>
+          </a:effectRef>
+          <a:fontRef idx="minor">
+            <a:schemeClr val="lt1"/>
+          </a:fontRef>
+        </p:style>
+        <p:txBody>
+          <a:bodyPr rtlCol="0" anchor="ctr"/>
+          <a:lstStyle/>
+          <a:p>
+            <a:pPr algn="ctr"/>
+          </a:p>
+        </p:txBody>
+      </p:sp>
+      <p:sp>
+        <p:nvSpPr>
+          <p:cNvPr id="8" name="TextBox 7"/>
+          <p:cNvSpPr txBox="1"/>
+          <p:nvPr/>
+        </p:nvSpPr>
+        <p:spPr>
+          <a:xfrm>
+            <a:off x="180000" y="6390000"/>
+            <a:ext cx="11700000" cy="450000"/>
+          </a:xfrm>
+          <a:prstGeom prst="rect">
+            <a:avLst/>
+          </a:prstGeom>
+          <a:noFill/>
+        </p:spPr>
+        <p:txBody>
+          <a:bodyPr wrap="square">
+            <a:spAutoFit/>
+          </a:bodyPr>
+          <a:lstStyle/>
+          <a:p>
+            <a:pPr algn="l"/>
+            <a:r>
+              <a:rPr sz="1000" b="1" i="0">
+                <a:solidFill>
+                  <a:srgbClr val="FF8C42"/>
+                </a:solidFill>
+              </a:rPr>
+              <a:t>ВЫВОД: Банки температурно симметричны. Цил.6 достигает 606°C — КРИТИЧНО.</a:t>
+            </a:r>
+          </a:p>
+        </p:txBody>
+      </p:sp>
+    </p:spTree>
+  </p:cSld>
+  <p:clrMapOvr>
+    <a:masterClrMapping/>
+  </p:clrMapOvr>
+</p:sld>
+</file>
+
+<file path=ppt/slides/slide22.xml><?xml version="1.0" encoding="utf-8"?>
+<p:sld xmlns:a="http://schemas.openxmlformats.org/drawingml/2006/main" xmlns:p="http://schemas.openxmlformats.org/presentationml/2006/main" xmlns:r="http://schemas.openxmlformats.org/officeDocument/2006/relationships">
+  <p:cSld>
+    <p:bg>
+      <p:bgPr>
+        <a:solidFill>
+          <a:srgbClr val="293136"/>
+        </a:solidFill>
+        <a:effectLst/>
+      </p:bgPr>
+    </p:bg>
+    <p:spTree>
+      <p:nvGrpSpPr>
+        <p:cNvPr id="1" name=""/>
+        <p:cNvGrpSpPr/>
+        <p:nvPr/>
+      </p:nvGrpSpPr>
+      <p:grpSpPr/>
+      <p:sp>
+        <p:nvSpPr>
+          <p:cNvPr id="2" name="Rectangle 1"/>
+          <p:cNvSpPr/>
+          <p:nvPr/>
+        </p:nvSpPr>
+        <p:spPr>
+          <a:xfrm>
+            <a:off x="0" y="0"/>
+            <a:ext cx="12189600" cy="720000"/>
+          </a:xfrm>
+          <a:prstGeom prst="rect">
+            <a:avLst/>
+          </a:prstGeom>
+          <a:solidFill>
+            <a:srgbClr val="20272B"/>
+          </a:solidFill>
+          <a:ln>
+            <a:noFill/>
+          </a:ln>
+        </p:spPr>
+        <p:style>
+          <a:lnRef idx="1">
+            <a:schemeClr val="accent1"/>
+          </a:lnRef>
+          <a:fillRef idx="3">
+            <a:schemeClr val="accent1"/>
+          </a:fillRef>
+          <a:effectRef idx="2">
+            <a:schemeClr val="accent1"/>
+          </a:effectRef>
+          <a:fontRef idx="minor">
+            <a:schemeClr val="lt1"/>
+          </a:fontRef>
+        </p:style>
+        <p:txBody>
+          <a:bodyPr rtlCol="0" anchor="ctr"/>
+          <a:lstStyle/>
+          <a:p>
+            <a:pPr algn="ctr"/>
+          </a:p>
+        </p:txBody>
+      </p:sp>
+      <p:sp>
+        <p:nvSpPr>
+          <p:cNvPr id="3" name="Rectangle 2"/>
+          <p:cNvSpPr/>
+          <p:nvPr/>
+        </p:nvSpPr>
+        <p:spPr>
+          <a:xfrm>
+            <a:off x="0" y="666000"/>
+            <a:ext cx="12189600" cy="43200"/>
+          </a:xfrm>
+          <a:prstGeom prst="rect">
+            <a:avLst/>
+          </a:prstGeom>
+          <a:solidFill>
+            <a:srgbClr val="3EF0AF"/>
+          </a:solidFill>
+          <a:ln>
+            <a:noFill/>
+          </a:ln>
+        </p:spPr>
+        <p:style>
+          <a:lnRef idx="1">
+            <a:schemeClr val="accent1"/>
+          </a:lnRef>
+          <a:fillRef idx="3">
+            <a:schemeClr val="accent1"/>
+          </a:fillRef>
+          <a:effectRef idx="2">
+            <a:schemeClr val="accent1"/>
+          </a:effectRef>
+          <a:fontRef idx="minor">
+            <a:schemeClr val="lt1"/>
+          </a:fontRef>
+        </p:style>
+        <p:txBody>
+          <a:bodyPr rtlCol="0" anchor="ctr"/>
+          <a:lstStyle/>
+          <a:p>
+            <a:pPr algn="ctr"/>
+          </a:p>
+        </p:txBody>
+      </p:sp>
+      <p:sp>
+        <p:nvSpPr>
+          <p:cNvPr id="4" name="TextBox 3"/>
+          <p:cNvSpPr txBox="1"/>
+          <p:nvPr/>
+        </p:nvSpPr>
+        <p:spPr>
+          <a:xfrm>
+            <a:off x="180000" y="36000"/>
+            <a:ext cx="11520000" cy="396000"/>
+          </a:xfrm>
+          <a:prstGeom prst="rect">
+            <a:avLst/>
+          </a:prstGeom>
+          <a:noFill/>
+        </p:spPr>
+        <p:txBody>
+          <a:bodyPr wrap="square">
+            <a:spAutoFit/>
+          </a:bodyPr>
+          <a:lstStyle/>
+          <a:p>
+            <a:pPr algn="l"/>
+            <a:r>
+              <a:rPr sz="1600" b="1" i="0">
+                <a:solidFill>
+                  <a:srgbClr val="FFFFFF"/>
+                </a:solidFill>
+              </a:rPr>
+              <a:t>ТЕМПЕРАТУРА ЦИЛИНДРОВ — АГРЕГАТ #87  |  21.05.2026</a:t>
+            </a:r>
+          </a:p>
+        </p:txBody>
+      </p:sp>
+      <p:sp>
+        <p:nvSpPr>
+          <p:cNvPr id="5" name="TextBox 4"/>
+          <p:cNvSpPr txBox="1"/>
+          <p:nvPr/>
+        </p:nvSpPr>
+        <p:spPr>
+          <a:xfrm>
+            <a:off x="180000" y="432000"/>
+            <a:ext cx="11520000" cy="234000"/>
+          </a:xfrm>
+          <a:prstGeom prst="rect">
+            <a:avLst/>
+          </a:prstGeom>
+          <a:noFill/>
+        </p:spPr>
+        <p:txBody>
+          <a:bodyPr wrap="square">
+            <a:spAutoFit/>
+          </a:bodyPr>
+          <a:lstStyle/>
+          <a:p>
+            <a:pPr algn="l"/>
+            <a:r>
+              <a:rPr sz="950" b="0" i="0">
+                <a:solidFill>
+                  <a:srgbClr val="667788"/>
+                </a:solidFill>
+              </a:rPr>
+              <a:t>А-банк (нечётные, ECM144) — В-банк (чётные, ECM1)  |  Индивидуальные ЕГТ по цилиндрам</a:t>
+            </a:r>
+          </a:p>
+        </p:txBody>
+      </p:sp>
+      <p:pic>
+        <p:nvPicPr>
+          <p:cNvPr id="6" name="Picture 5" descr="tmpzs_bprnl.png"/>
+          <p:cNvPicPr>
+            <a:picLocks noChangeAspect="1"/>
+          </p:cNvPicPr>
+          <p:nvPr/>
+        </p:nvPicPr>
+        <p:blipFill>
+          <a:blip r:embed="rId2"/>
+          <a:stretch>
+            <a:fillRect/>
+          </a:stretch>
+        </p:blipFill>
+        <p:spPr>
+          <a:xfrm>
+            <a:off x="108000" y="756000"/>
+            <a:ext cx="11952000" cy="5580000"/>
+          </a:xfrm>
+          <a:prstGeom prst="rect">
+            <a:avLst/>
+          </a:prstGeom>
+        </p:spPr>
+      </p:pic>
+      <p:sp>
+        <p:nvSpPr>
+          <p:cNvPr id="7" name="Rectangle 6"/>
+          <p:cNvSpPr/>
+          <p:nvPr/>
+        </p:nvSpPr>
+        <p:spPr>
+          <a:xfrm>
+            <a:off x="0" y="6372000"/>
+            <a:ext cx="12189600" cy="486000"/>
+          </a:xfrm>
+          <a:prstGeom prst="rect">
+            <a:avLst/>
+          </a:prstGeom>
+          <a:solidFill>
+            <a:srgbClr val="20272B"/>
+          </a:solidFill>
+          <a:ln w="15240">
+            <a:solidFill>
+              <a:srgbClr val="FF8C42"/>
+            </a:solidFill>
+          </a:ln>
+        </p:spPr>
+        <p:style>
+          <a:lnRef idx="1">
+            <a:schemeClr val="accent1"/>
+          </a:lnRef>
+          <a:fillRef idx="3">
+            <a:schemeClr val="accent1"/>
+          </a:fillRef>
+          <a:effectRef idx="2">
+            <a:schemeClr val="accent1"/>
+          </a:effectRef>
+          <a:fontRef idx="minor">
+            <a:schemeClr val="lt1"/>
+          </a:fontRef>
+        </p:style>
+        <p:txBody>
+          <a:bodyPr rtlCol="0" anchor="ctr"/>
+          <a:lstStyle/>
+          <a:p>
+            <a:pPr algn="ctr"/>
+          </a:p>
+        </p:txBody>
+      </p:sp>
+      <p:sp>
+        <p:nvSpPr>
+          <p:cNvPr id="8" name="TextBox 7"/>
+          <p:cNvSpPr txBox="1"/>
+          <p:nvPr/>
+        </p:nvSpPr>
+        <p:spPr>
+          <a:xfrm>
+            <a:off x="180000" y="6390000"/>
+            <a:ext cx="11700000" cy="450000"/>
+          </a:xfrm>
+          <a:prstGeom prst="rect">
+            <a:avLst/>
+          </a:prstGeom>
+          <a:noFill/>
+        </p:spPr>
+        <p:txBody>
+          <a:bodyPr wrap="square">
+            <a:spAutoFit/>
+          </a:bodyPr>
+          <a:lstStyle/>
+          <a:p>
+            <a:pPr algn="l"/>
+            <a:r>
+              <a:rPr sz="1000" b="1" i="0">
+                <a:solidFill>
+                  <a:srgbClr val="FF8C42"/>
+                </a:solidFill>
+              </a:rPr>
+              <a:t>ВЫВОД: А-банк горячее В-банка на 17°C в среднем. Цил.1 достигает 550°C — КРИТИЧНО.</a:t>
             </a:r>
           </a:p>
         </p:txBody>

</xml_diff>